<commit_message>
Replace native charts with images for Keynote compatibility; add PDF
Co-Authored-By: Claude Opus 5.5 <noreply@anthropic.com>
Claude-Session: https://claude.ai/code/session_017GiyhuFzqhfbUGRqn21vyt
</commit_message>
<xml_diff>
--- a/Instagram強化プラン_山田歯科.pptx
+++ b/Instagram強化プラン_山田歯科.pptx
@@ -120,13 +120,13 @@
   <p:extLst>
     <p:ext uri="{521415D9-36F7-43E2-AB2F-B90AF26B5E84}">
       <p14:sectionLst xmlns:p14="http://schemas.microsoft.com/office/powerpoint/2010/main">
-        <p14:section name="はじめに" id="{63d6f0ff-0023-b624-b72e-ada7e0c88c20}">
+        <p14:section name="はじめに" id="{7819d5b8-5d21-22ee-8ef9-e5a077671608}">
           <p14:sldIdLst>
             <p14:sldId id="256"/>
             <p14:sldId id="257"/>
           </p14:sldIdLst>
         </p14:section>
-        <p14:section name="現状分析" id="{d6704dfd-395d-a272-dd06-44573b00db96}">
+        <p14:section name="現状分析" id="{8eb2106f-e12e-6b5b-b5bd-bdd5c2b659be}">
           <p14:sldIdLst>
             <p14:sldId id="258"/>
             <p14:sldId id="259"/>
@@ -135,21 +135,21 @@
             <p14:sldId id="262"/>
           </p14:sldIdLst>
         </p14:section>
-        <p14:section name="競合比較" id="{5046e5b0-34b3-245f-66ac-7d5b57da399e}">
+        <p14:section name="競合比較" id="{0ec5ecde-c269-00b6-e7ec-bd662c652c8d}">
           <p14:sldIdLst>
             <p14:sldId id="263"/>
             <p14:sldId id="264"/>
             <p14:sldId id="265"/>
           </p14:sldIdLst>
         </p14:section>
-        <p14:section name="改善施策" id="{9171f6f1-88f1-9def-59da-49651e806cdc}">
+        <p14:section name="改善施策" id="{3b641722-7e34-429c-a729-a3d5bf0a347a}">
           <p14:sldIdLst>
             <p14:sldId id="266"/>
             <p14:sldId id="267"/>
             <p14:sldId id="268"/>
           </p14:sldIdLst>
         </p14:section>
-        <p14:section name="まとめ" id="{ecec0201-47bb-bc94-f9d0-bce97ac60d83}">
+        <p14:section name="まとめ" id="{8c687afa-0a88-fa23-cf2a-856ea211e20f}">
           <p14:sldIdLst>
             <p14:sldId id="269"/>
           </p14:sldIdLst>
@@ -161,1477 +161,6 @@
     </p:ext>
   </p:extLst>
 </p:presentation>
-</file>
-
-<file path=ppt/charts/chart1.xml><?xml version="1.0" encoding="utf-8"?>
-<c:chartSpace xmlns:c="http://schemas.openxmlformats.org/drawingml/2006/chart" xmlns:a="http://schemas.openxmlformats.org/drawingml/2006/main" xmlns:r="http://schemas.openxmlformats.org/officeDocument/2006/relationships">
-  <c:date1904 val="0"/>
-  <c:roundedCorners val="1"/>
-  <c:chart>
-    <c:title>
-      <c:tx>
-        <c:rich>
-          <a:bodyPr/>
-          <a:lstStyle/>
-          <a:p>
-            <a:pPr>
-              <a:defRPr sz="1200" b="0" i="0" u="none" strike="noStrike">
-                <a:solidFill>
-                  <a:srgbClr val="0F4C5C"/>
-                </a:solidFill>
-                <a:latin typeface="+mn-lt"/>
-              </a:defRPr>
-            </a:pPr>
-            <a:r>
-              <a:rPr sz="1200" b="0" i="0" u="none" strike="noStrike">
-                <a:solidFill>
-                  <a:srgbClr val="0F4C5C"/>
-                </a:solidFill>
-                <a:latin typeface="+mn-lt"/>
-              </a:rPr>
-              <a:t>月別・1投稿あたりの平均表示回数</a:t>
-            </a:r>
-          </a:p>
-        </c:rich>
-      </c:tx>
-      <c:layout/>
-      <c:overlay val="0"/>
-    </c:title>
-    <c:autoTitleDeleted val="0"/>
-    <c:plotArea>
-      <c:layout/>
-      <c:barChart>
-        <c:barDir val="col"/>
-        <c:grouping val="clustered"/>
-        <c:varyColors val="0"/>
-        <c:ser>
-          <c:idx val="0"/>
-          <c:order val="0"/>
-          <c:tx>
-            <c:strRef>
-              <c:f>Sheet1!$B$1</c:f>
-              <c:strCache>
-                <c:ptCount val="1"/>
-                <c:pt idx="0">
-                  <c:v>平均表示回数</c:v>
-                </c:pt>
-              </c:strCache>
-            </c:strRef>
-          </c:tx>
-          <c:spPr>
-            <a:solidFill>
-              <a:srgbClr val="2A9D8F"/>
-            </a:solidFill>
-            <a:effectLst/>
-          </c:spPr>
-          <c:invertIfNegative val="0"/>
-          <c:dLbls>
-            <c:numFmt formatCode="#,##0" sourceLinked="0"/>
-            <c:txPr>
-              <a:bodyPr/>
-              <a:lstStyle/>
-              <a:p>
-                <a:pPr>
-                  <a:defRPr b="0" i="0" strike="noStrike" sz="1000" u="none">
-                    <a:solidFill>
-                      <a:srgbClr val="1F2A30"/>
-                    </a:solidFill>
-                    <a:latin typeface="+mn-lt"/>
-                  </a:defRPr>
-                </a:pPr>
-              </a:p>
-            </c:txPr>
-            <c:showLegendKey val="0"/>
-            <c:showVal val="1"/>
-            <c:showCatName val="0"/>
-            <c:showSerName val="0"/>
-            <c:showPercent val="0"/>
-            <c:showBubbleSize val="0"/>
-            <c:showLeaderLines val="0"/>
-          </c:dLbls>
-          <c:cat>
-            <c:multiLvlStrRef>
-              <c:f>Sheet1!$A$2:$A$14</c:f>
-              <c:multiLvlStrCache>
-                <c:ptCount val="13"/>
-                <c:lvl>
-                  <c:pt idx="0">
-                    <c:v>25/4</c:v>
-                  </c:pt>
-                  <c:pt idx="1">
-                    <c:v>25/5</c:v>
-                  </c:pt>
-                  <c:pt idx="2">
-                    <c:v>25/6</c:v>
-                  </c:pt>
-                  <c:pt idx="3">
-                    <c:v>25/8</c:v>
-                  </c:pt>
-                  <c:pt idx="4">
-                    <c:v>25/9</c:v>
-                  </c:pt>
-                  <c:pt idx="5">
-                    <c:v>25/10</c:v>
-                  </c:pt>
-                  <c:pt idx="6">
-                    <c:v>25/11</c:v>
-                  </c:pt>
-                  <c:pt idx="7">
-                    <c:v>26/2</c:v>
-                  </c:pt>
-                  <c:pt idx="8">
-                    <c:v>26/3</c:v>
-                  </c:pt>
-                  <c:pt idx="9">
-                    <c:v>26/6</c:v>
-                  </c:pt>
-                  <c:pt idx="10">
-                    <c:v>26/8</c:v>
-                  </c:pt>
-                  <c:pt idx="11">
-                    <c:v>26/9</c:v>
-                  </c:pt>
-                  <c:pt idx="12">
-                    <c:v>26/10</c:v>
-                  </c:pt>
-                </c:lvl>
-              </c:multiLvlStrCache>
-            </c:multiLvlStrRef>
-          </c:cat>
-          <c:val>
-            <c:numRef>
-              <c:f>Sheet1!$B$2:$B$14</c:f>
-              <c:numCache>
-                <c:formatCode>General</c:formatCode>
-                <c:ptCount val="13"/>
-                <c:pt idx="0">
-                  <c:v>3096</c:v>
-                </c:pt>
-                <c:pt idx="1">
-                  <c:v>4271</c:v>
-                </c:pt>
-                <c:pt idx="2">
-                  <c:v>4356</c:v>
-                </c:pt>
-                <c:pt idx="3">
-                  <c:v>2729</c:v>
-                </c:pt>
-                <c:pt idx="4">
-                  <c:v>2511</c:v>
-                </c:pt>
-                <c:pt idx="5">
-                  <c:v>3658</c:v>
-                </c:pt>
-                <c:pt idx="6">
-                  <c:v>2449</c:v>
-                </c:pt>
-                <c:pt idx="7">
-                  <c:v>965</c:v>
-                </c:pt>
-                <c:pt idx="8">
-                  <c:v>866</c:v>
-                </c:pt>
-                <c:pt idx="9">
-                  <c:v>1235</c:v>
-                </c:pt>
-                <c:pt idx="10">
-                  <c:v>712</c:v>
-                </c:pt>
-                <c:pt idx="11">
-                  <c:v>1038</c:v>
-                </c:pt>
-                <c:pt idx="12">
-                  <c:v>807</c:v>
-                </c:pt>
-              </c:numCache>
-            </c:numRef>
-          </c:val>
-        </c:ser>
-        <c:dLbls>
-          <c:numFmt formatCode="#,##0" sourceLinked="0"/>
-          <c:txPr>
-            <a:bodyPr/>
-            <a:lstStyle/>
-            <a:p>
-              <a:pPr>
-                <a:defRPr b="0" i="0" strike="noStrike" sz="1000" u="none">
-                  <a:solidFill>
-                    <a:srgbClr val="1F2A30"/>
-                  </a:solidFill>
-                  <a:latin typeface="+mn-lt"/>
-                </a:defRPr>
-              </a:pPr>
-            </a:p>
-          </c:txPr>
-          <c:showLegendKey val="0"/>
-          <c:showVal val="1"/>
-          <c:showCatName val="0"/>
-          <c:showSerName val="0"/>
-          <c:showPercent val="0"/>
-          <c:showBubbleSize val="0"/>
-          <c:showLeaderLines val="0"/>
-        </c:dLbls>
-        <c:gapWidth val="150"/>
-        <c:overlap val="0"/>
-        <c:axId val="2094734554"/>
-        <c:axId val="2094734552"/>
-        <c:axId val="2094734556"/>
-      </c:barChart>
-      <c:catAx>
-        <c:axId val="2094734554"/>
-        <c:scaling>
-          <c:orientation val="minMax"/>
-        </c:scaling>
-        <c:delete val="0"/>
-        <c:axPos val="b"/>
-        <c:numFmt formatCode="General" sourceLinked="1"/>
-        <c:majorTickMark val="out"/>
-        <c:minorTickMark val="none"/>
-        <c:tickLblPos val="low"/>
-        <c:spPr>
-          <a:ln w="12700" cap="flat">
-            <a:solidFill>
-              <a:srgbClr val="888888"/>
-            </a:solidFill>
-            <a:prstDash val="solid"/>
-            <a:round/>
-          </a:ln>
-        </c:spPr>
-        <c:txPr>
-          <a:bodyPr/>
-          <a:lstStyle/>
-          <a:p>
-            <a:pPr>
-              <a:defRPr sz="1000" b="0" i="0" u="none" strike="noStrike">
-                <a:solidFill>
-                  <a:srgbClr val="6B7A80"/>
-                </a:solidFill>
-                <a:latin typeface="+mn-lt"/>
-              </a:defRPr>
-            </a:pPr>
-            <a:endParaRPr lang="en-US"/>
-          </a:p>
-        </c:txPr>
-        <c:crossAx val="2094734552"/>
-        <c:crosses val="autoZero"/>
-        <c:auto val="1"/>
-        <c:lblAlgn val="ctr"/>
-        <c:noMultiLvlLbl val="1"/>
-      </c:catAx>
-      <c:valAx>
-        <c:axId val="2094734552"/>
-        <c:scaling>
-          <c:orientation val="minMax"/>
-        </c:scaling>
-        <c:delete val="0"/>
-        <c:axPos val="l"/>
-        <c:majorGridlines>
-          <c:spPr>
-            <a:ln w="6350" cap="flat">
-              <a:solidFill>
-                <a:srgbClr val="D7E3E1"/>
-              </a:solidFill>
-              <a:prstDash val="solid"/>
-              <a:round/>
-            </a:ln>
-          </c:spPr>
-        </c:majorGridlines>
-        <c:numFmt formatCode="#,##0" sourceLinked="0"/>
-        <c:majorTickMark val="out"/>
-        <c:minorTickMark val="none"/>
-        <c:tickLblPos val="nextTo"/>
-        <c:spPr>
-          <a:ln w="12700" cap="flat">
-            <a:solidFill>
-              <a:srgbClr val="888888"/>
-            </a:solidFill>
-            <a:prstDash val="solid"/>
-            <a:round/>
-          </a:ln>
-        </c:spPr>
-        <c:txPr>
-          <a:bodyPr/>
-          <a:lstStyle/>
-          <a:p>
-            <a:pPr>
-              <a:defRPr sz="1000" b="0" i="0" u="none" strike="noStrike">
-                <a:solidFill>
-                  <a:srgbClr val="6B7A80"/>
-                </a:solidFill>
-                <a:latin typeface="+mn-lt"/>
-              </a:defRPr>
-            </a:pPr>
-            <a:endParaRPr lang="en-US"/>
-          </a:p>
-        </c:txPr>
-        <c:crossAx val="2094734554"/>
-        <c:crosses val="autoZero"/>
-        <c:crossBetween val="between"/>
-      </c:valAx>
-      <c:spPr>
-        <a:noFill/>
-        <a:ln>
-          <a:noFill/>
-        </a:ln>
-        <a:effectLst/>
-      </c:spPr>
-    </c:plotArea>
-    <c:plotVisOnly val="1"/>
-    <c:dispBlanksAs val="span"/>
-  </c:chart>
-  <c:spPr>
-    <a:noFill/>
-    <a:ln>
-      <a:noFill/>
-    </a:ln>
-    <a:effectLst/>
-  </c:spPr>
-  <c:externalData r:id="rId1">
-    <c:autoUpdate val="0"/>
-  </c:externalData>
-</c:chartSpace>
-</file>
-
-<file path=ppt/charts/chart2.xml><?xml version="1.0" encoding="utf-8"?>
-<c:chartSpace xmlns:c="http://schemas.openxmlformats.org/drawingml/2006/chart" xmlns:a="http://schemas.openxmlformats.org/drawingml/2006/main" xmlns:r="http://schemas.openxmlformats.org/officeDocument/2006/relationships">
-  <c:date1904 val="0"/>
-  <c:roundedCorners val="1"/>
-  <c:chart>
-    <c:title>
-      <c:tx>
-        <c:rich>
-          <a:bodyPr/>
-          <a:lstStyle/>
-          <a:p>
-            <a:pPr>
-              <a:defRPr sz="1200" b="0" i="0" u="none" strike="noStrike">
-                <a:solidFill>
-                  <a:srgbClr val="0F4C5C"/>
-                </a:solidFill>
-                <a:latin typeface="+mn-lt"/>
-              </a:defRPr>
-            </a:pPr>
-            <a:r>
-              <a:rPr sz="1200" b="0" i="0" u="none" strike="noStrike">
-                <a:solidFill>
-                  <a:srgbClr val="0F4C5C"/>
-                </a:solidFill>
-                <a:latin typeface="+mn-lt"/>
-              </a:rPr>
-              <a:t>平均リーチ（人）</a:t>
-            </a:r>
-          </a:p>
-        </c:rich>
-      </c:tx>
-      <c:layout/>
-      <c:overlay val="0"/>
-    </c:title>
-    <c:autoTitleDeleted val="0"/>
-    <c:plotArea>
-      <c:layout/>
-      <c:barChart>
-        <c:barDir val="bar"/>
-        <c:grouping val="clustered"/>
-        <c:varyColors val="0"/>
-        <c:ser>
-          <c:idx val="0"/>
-          <c:order val="0"/>
-          <c:tx>
-            <c:strRef>
-              <c:f>Sheet1!$B$1</c:f>
-              <c:strCache>
-                <c:ptCount val="1"/>
-                <c:pt idx="0">
-                  <c:v>平均リーチ</c:v>
-                </c:pt>
-              </c:strCache>
-            </c:strRef>
-          </c:tx>
-          <c:spPr>
-            <a:solidFill>
-              <a:srgbClr val="2A9D8F"/>
-            </a:solidFill>
-            <a:effectLst/>
-          </c:spPr>
-          <c:invertIfNegative val="0"/>
-          <c:dLbls>
-            <c:numFmt formatCode="#,##0" sourceLinked="0"/>
-            <c:txPr>
-              <a:bodyPr/>
-              <a:lstStyle/>
-              <a:p>
-                <a:pPr>
-                  <a:defRPr b="0" i="0" strike="noStrike" sz="1000" u="none">
-                    <a:solidFill>
-                      <a:srgbClr val="1F2A30"/>
-                    </a:solidFill>
-                    <a:latin typeface="+mn-lt"/>
-                  </a:defRPr>
-                </a:pPr>
-              </a:p>
-            </c:txPr>
-            <c:showLegendKey val="0"/>
-            <c:showVal val="1"/>
-            <c:showCatName val="0"/>
-            <c:showSerName val="0"/>
-            <c:showPercent val="0"/>
-            <c:showBubbleSize val="0"/>
-            <c:showLeaderLines val="0"/>
-          </c:dLbls>
-          <c:cat>
-            <c:multiLvlStrRef>
-              <c:f>Sheet1!$A$2:$A$6</c:f>
-              <c:multiLvlStrCache>
-                <c:ptCount val="5"/>
-                <c:lvl>
-                  <c:pt idx="0">
-                    <c:v>人物・院内紹介</c:v>
-                  </c:pt>
-                  <c:pt idx="1">
-                    <c:v>ホワイトニング</c:v>
-                  </c:pt>
-                  <c:pt idx="2">
-                    <c:v>口コミ紹介</c:v>
-                  </c:pt>
-                  <c:pt idx="3">
-                    <c:v>物販</c:v>
-                  </c:pt>
-                  <c:pt idx="4">
-                    <c:v>症例（年齢・主訴）</c:v>
-                  </c:pt>
-                </c:lvl>
-              </c:multiLvlStrCache>
-            </c:multiLvlStrRef>
-          </c:cat>
-          <c:val>
-            <c:numRef>
-              <c:f>Sheet1!$B$2:$B$6</c:f>
-              <c:numCache>
-                <c:formatCode>General</c:formatCode>
-                <c:ptCount val="5"/>
-                <c:pt idx="0">
-                  <c:v>797</c:v>
-                </c:pt>
-                <c:pt idx="1">
-                  <c:v>547</c:v>
-                </c:pt>
-                <c:pt idx="2">
-                  <c:v>430</c:v>
-                </c:pt>
-                <c:pt idx="3">
-                  <c:v>423</c:v>
-                </c:pt>
-                <c:pt idx="4">
-                  <c:v>374</c:v>
-                </c:pt>
-              </c:numCache>
-            </c:numRef>
-          </c:val>
-        </c:ser>
-        <c:dLbls>
-          <c:numFmt formatCode="#,##0" sourceLinked="0"/>
-          <c:txPr>
-            <a:bodyPr/>
-            <a:lstStyle/>
-            <a:p>
-              <a:pPr>
-                <a:defRPr b="0" i="0" strike="noStrike" sz="1000" u="none">
-                  <a:solidFill>
-                    <a:srgbClr val="1F2A30"/>
-                  </a:solidFill>
-                  <a:latin typeface="+mn-lt"/>
-                </a:defRPr>
-              </a:pPr>
-            </a:p>
-          </c:txPr>
-          <c:showLegendKey val="0"/>
-          <c:showVal val="1"/>
-          <c:showCatName val="0"/>
-          <c:showSerName val="0"/>
-          <c:showPercent val="0"/>
-          <c:showBubbleSize val="0"/>
-          <c:showLeaderLines val="0"/>
-        </c:dLbls>
-        <c:gapWidth val="150"/>
-        <c:overlap val="0"/>
-        <c:axId val="2094734554"/>
-        <c:axId val="2094734552"/>
-        <c:axId val="2094734556"/>
-      </c:barChart>
-      <c:catAx>
-        <c:axId val="2094734554"/>
-        <c:scaling>
-          <c:orientation val="maxMin"/>
-        </c:scaling>
-        <c:delete val="0"/>
-        <c:axPos val="l"/>
-        <c:numFmt formatCode="General" sourceLinked="1"/>
-        <c:majorTickMark val="out"/>
-        <c:minorTickMark val="none"/>
-        <c:tickLblPos val="nextTo"/>
-        <c:spPr>
-          <a:ln w="12700" cap="flat">
-            <a:solidFill>
-              <a:srgbClr val="888888"/>
-            </a:solidFill>
-            <a:prstDash val="solid"/>
-            <a:round/>
-          </a:ln>
-        </c:spPr>
-        <c:txPr>
-          <a:bodyPr/>
-          <a:lstStyle/>
-          <a:p>
-            <a:pPr>
-              <a:defRPr sz="1000" b="0" i="0" u="none" strike="noStrike">
-                <a:solidFill>
-                  <a:srgbClr val="6B7A80"/>
-                </a:solidFill>
-                <a:latin typeface="+mn-lt"/>
-              </a:defRPr>
-            </a:pPr>
-            <a:endParaRPr lang="en-US"/>
-          </a:p>
-        </c:txPr>
-        <c:crossAx val="2094734552"/>
-        <c:crosses val="autoZero"/>
-        <c:auto val="1"/>
-        <c:lblAlgn val="ctr"/>
-        <c:noMultiLvlLbl val="1"/>
-      </c:catAx>
-      <c:valAx>
-        <c:axId val="2094734552"/>
-        <c:scaling>
-          <c:orientation val="minMax"/>
-        </c:scaling>
-        <c:delete val="0"/>
-        <c:axPos val="b"/>
-        <c:majorGridlines>
-          <c:spPr>
-            <a:ln w="6350" cap="flat">
-              <a:solidFill>
-                <a:srgbClr val="D7E3E1"/>
-              </a:solidFill>
-              <a:prstDash val="solid"/>
-              <a:round/>
-            </a:ln>
-          </c:spPr>
-        </c:majorGridlines>
-        <c:numFmt formatCode="General" sourceLinked="0"/>
-        <c:majorTickMark val="out"/>
-        <c:minorTickMark val="none"/>
-        <c:tickLblPos val="low"/>
-        <c:spPr>
-          <a:ln w="12700" cap="flat">
-            <a:solidFill>
-              <a:srgbClr val="888888"/>
-            </a:solidFill>
-            <a:prstDash val="solid"/>
-            <a:round/>
-          </a:ln>
-        </c:spPr>
-        <c:txPr>
-          <a:bodyPr/>
-          <a:lstStyle/>
-          <a:p>
-            <a:pPr>
-              <a:defRPr sz="1000" b="0" i="0" u="none" strike="noStrike">
-                <a:solidFill>
-                  <a:srgbClr val="6B7A80"/>
-                </a:solidFill>
-                <a:latin typeface="+mn-lt"/>
-              </a:defRPr>
-            </a:pPr>
-            <a:endParaRPr lang="en-US"/>
-          </a:p>
-        </c:txPr>
-        <c:crossAx val="2094734554"/>
-        <c:crosses val="autoZero"/>
-        <c:crossBetween val="between"/>
-      </c:valAx>
-      <c:spPr>
-        <a:noFill/>
-        <a:ln>
-          <a:noFill/>
-        </a:ln>
-        <a:effectLst/>
-      </c:spPr>
-    </c:plotArea>
-    <c:plotVisOnly val="1"/>
-    <c:dispBlanksAs val="span"/>
-  </c:chart>
-  <c:spPr>
-    <a:noFill/>
-    <a:ln>
-      <a:noFill/>
-    </a:ln>
-    <a:effectLst/>
-  </c:spPr>
-  <c:externalData r:id="rId1">
-    <c:autoUpdate val="0"/>
-  </c:externalData>
-</c:chartSpace>
-</file>
-
-<file path=ppt/charts/chart3.xml><?xml version="1.0" encoding="utf-8"?>
-<c:chartSpace xmlns:c="http://schemas.openxmlformats.org/drawingml/2006/chart" xmlns:a="http://schemas.openxmlformats.org/drawingml/2006/main" xmlns:r="http://schemas.openxmlformats.org/officeDocument/2006/relationships">
-  <c:date1904 val="0"/>
-  <c:roundedCorners val="1"/>
-  <c:chart>
-    <c:title>
-      <c:tx>
-        <c:rich>
-          <a:bodyPr/>
-          <a:lstStyle/>
-          <a:p>
-            <a:pPr>
-              <a:defRPr sz="1200" b="0" i="0" u="none" strike="noStrike">
-                <a:solidFill>
-                  <a:srgbClr val="0F4C5C"/>
-                </a:solidFill>
-                <a:latin typeface="+mn-lt"/>
-              </a:defRPr>
-            </a:pPr>
-            <a:r>
-              <a:rPr sz="1200" b="0" i="0" u="none" strike="noStrike">
-                <a:solidFill>
-                  <a:srgbClr val="0F4C5C"/>
-                </a:solidFill>
-                <a:latin typeface="+mn-lt"/>
-              </a:rPr>
-              <a:t>1投稿あたりプロフィール訪問（回）</a:t>
-            </a:r>
-          </a:p>
-        </c:rich>
-      </c:tx>
-      <c:layout/>
-      <c:overlay val="0"/>
-    </c:title>
-    <c:autoTitleDeleted val="0"/>
-    <c:plotArea>
-      <c:layout/>
-      <c:barChart>
-        <c:barDir val="bar"/>
-        <c:grouping val="clustered"/>
-        <c:varyColors val="0"/>
-        <c:ser>
-          <c:idx val="0"/>
-          <c:order val="0"/>
-          <c:tx>
-            <c:strRef>
-              <c:f>Sheet1!$B$1</c:f>
-              <c:strCache>
-                <c:ptCount val="1"/>
-                <c:pt idx="0">
-                  <c:v>プロフィール訪問</c:v>
-                </c:pt>
-              </c:strCache>
-            </c:strRef>
-          </c:tx>
-          <c:spPr>
-            <a:solidFill>
-              <a:srgbClr val="F28C6B"/>
-            </a:solidFill>
-            <a:effectLst/>
-          </c:spPr>
-          <c:invertIfNegative val="0"/>
-          <c:dLbls>
-            <c:numFmt formatCode="0.0" sourceLinked="0"/>
-            <c:txPr>
-              <a:bodyPr/>
-              <a:lstStyle/>
-              <a:p>
-                <a:pPr>
-                  <a:defRPr b="0" i="0" strike="noStrike" sz="1000" u="none">
-                    <a:solidFill>
-                      <a:srgbClr val="1F2A30"/>
-                    </a:solidFill>
-                    <a:latin typeface="+mn-lt"/>
-                  </a:defRPr>
-                </a:pPr>
-              </a:p>
-            </c:txPr>
-            <c:showLegendKey val="0"/>
-            <c:showVal val="1"/>
-            <c:showCatName val="0"/>
-            <c:showSerName val="0"/>
-            <c:showPercent val="0"/>
-            <c:showBubbleSize val="0"/>
-            <c:showLeaderLines val="0"/>
-          </c:dLbls>
-          <c:cat>
-            <c:multiLvlStrRef>
-              <c:f>Sheet1!$A$2:$A$6</c:f>
-              <c:multiLvlStrCache>
-                <c:ptCount val="5"/>
-                <c:lvl>
-                  <c:pt idx="0">
-                    <c:v>人物・院内紹介</c:v>
-                  </c:pt>
-                  <c:pt idx="1">
-                    <c:v>ホワイトニング</c:v>
-                  </c:pt>
-                  <c:pt idx="2">
-                    <c:v>口コミ紹介</c:v>
-                  </c:pt>
-                  <c:pt idx="3">
-                    <c:v>物販</c:v>
-                  </c:pt>
-                  <c:pt idx="4">
-                    <c:v>症例（年齢・主訴）</c:v>
-                  </c:pt>
-                </c:lvl>
-              </c:multiLvlStrCache>
-            </c:multiLvlStrRef>
-          </c:cat>
-          <c:val>
-            <c:numRef>
-              <c:f>Sheet1!$B$2:$B$6</c:f>
-              <c:numCache>
-                <c:formatCode>General</c:formatCode>
-                <c:ptCount val="5"/>
-                <c:pt idx="0">
-                  <c:v>14.9</c:v>
-                </c:pt>
-                <c:pt idx="1">
-                  <c:v>5.2</c:v>
-                </c:pt>
-                <c:pt idx="2">
-                  <c:v>7.2</c:v>
-                </c:pt>
-                <c:pt idx="3">
-                  <c:v>4</c:v>
-                </c:pt>
-                <c:pt idx="4">
-                  <c:v>7.7</c:v>
-                </c:pt>
-              </c:numCache>
-            </c:numRef>
-          </c:val>
-        </c:ser>
-        <c:dLbls>
-          <c:numFmt formatCode="0.0" sourceLinked="0"/>
-          <c:txPr>
-            <a:bodyPr/>
-            <a:lstStyle/>
-            <a:p>
-              <a:pPr>
-                <a:defRPr b="0" i="0" strike="noStrike" sz="1000" u="none">
-                  <a:solidFill>
-                    <a:srgbClr val="1F2A30"/>
-                  </a:solidFill>
-                  <a:latin typeface="+mn-lt"/>
-                </a:defRPr>
-              </a:pPr>
-            </a:p>
-          </c:txPr>
-          <c:showLegendKey val="0"/>
-          <c:showVal val="1"/>
-          <c:showCatName val="0"/>
-          <c:showSerName val="0"/>
-          <c:showPercent val="0"/>
-          <c:showBubbleSize val="0"/>
-          <c:showLeaderLines val="0"/>
-        </c:dLbls>
-        <c:gapWidth val="150"/>
-        <c:overlap val="0"/>
-        <c:axId val="2094734554"/>
-        <c:axId val="2094734552"/>
-        <c:axId val="2094734556"/>
-      </c:barChart>
-      <c:catAx>
-        <c:axId val="2094734554"/>
-        <c:scaling>
-          <c:orientation val="maxMin"/>
-        </c:scaling>
-        <c:delete val="0"/>
-        <c:axPos val="l"/>
-        <c:numFmt formatCode="General" sourceLinked="1"/>
-        <c:majorTickMark val="out"/>
-        <c:minorTickMark val="none"/>
-        <c:tickLblPos val="nextTo"/>
-        <c:spPr>
-          <a:ln w="12700" cap="flat">
-            <a:solidFill>
-              <a:srgbClr val="888888"/>
-            </a:solidFill>
-            <a:prstDash val="solid"/>
-            <a:round/>
-          </a:ln>
-        </c:spPr>
-        <c:txPr>
-          <a:bodyPr/>
-          <a:lstStyle/>
-          <a:p>
-            <a:pPr>
-              <a:defRPr sz="1000" b="0" i="0" u="none" strike="noStrike">
-                <a:solidFill>
-                  <a:srgbClr val="6B7A80"/>
-                </a:solidFill>
-                <a:latin typeface="+mn-lt"/>
-              </a:defRPr>
-            </a:pPr>
-            <a:endParaRPr lang="en-US"/>
-          </a:p>
-        </c:txPr>
-        <c:crossAx val="2094734552"/>
-        <c:crosses val="autoZero"/>
-        <c:auto val="1"/>
-        <c:lblAlgn val="ctr"/>
-        <c:noMultiLvlLbl val="1"/>
-      </c:catAx>
-      <c:valAx>
-        <c:axId val="2094734552"/>
-        <c:scaling>
-          <c:orientation val="minMax"/>
-        </c:scaling>
-        <c:delete val="0"/>
-        <c:axPos val="b"/>
-        <c:majorGridlines>
-          <c:spPr>
-            <a:ln w="6350" cap="flat">
-              <a:solidFill>
-                <a:srgbClr val="D7E3E1"/>
-              </a:solidFill>
-              <a:prstDash val="solid"/>
-              <a:round/>
-            </a:ln>
-          </c:spPr>
-        </c:majorGridlines>
-        <c:numFmt formatCode="General" sourceLinked="0"/>
-        <c:majorTickMark val="out"/>
-        <c:minorTickMark val="none"/>
-        <c:tickLblPos val="low"/>
-        <c:spPr>
-          <a:ln w="12700" cap="flat">
-            <a:solidFill>
-              <a:srgbClr val="888888"/>
-            </a:solidFill>
-            <a:prstDash val="solid"/>
-            <a:round/>
-          </a:ln>
-        </c:spPr>
-        <c:txPr>
-          <a:bodyPr/>
-          <a:lstStyle/>
-          <a:p>
-            <a:pPr>
-              <a:defRPr sz="1000" b="0" i="0" u="none" strike="noStrike">
-                <a:solidFill>
-                  <a:srgbClr val="6B7A80"/>
-                </a:solidFill>
-                <a:latin typeface="+mn-lt"/>
-              </a:defRPr>
-            </a:pPr>
-            <a:endParaRPr lang="en-US"/>
-          </a:p>
-        </c:txPr>
-        <c:crossAx val="2094734554"/>
-        <c:crosses val="autoZero"/>
-        <c:crossBetween val="between"/>
-      </c:valAx>
-      <c:spPr>
-        <a:noFill/>
-        <a:ln>
-          <a:noFill/>
-        </a:ln>
-        <a:effectLst/>
-      </c:spPr>
-    </c:plotArea>
-    <c:plotVisOnly val="1"/>
-    <c:dispBlanksAs val="span"/>
-  </c:chart>
-  <c:spPr>
-    <a:noFill/>
-    <a:ln>
-      <a:noFill/>
-    </a:ln>
-    <a:effectLst/>
-  </c:spPr>
-  <c:externalData r:id="rId1">
-    <c:autoUpdate val="0"/>
-  </c:externalData>
-</c:chartSpace>
-</file>
-
-<file path=ppt/charts/chart4.xml><?xml version="1.0" encoding="utf-8"?>
-<c:chartSpace xmlns:c="http://schemas.openxmlformats.org/drawingml/2006/chart" xmlns:a="http://schemas.openxmlformats.org/drawingml/2006/main" xmlns:r="http://schemas.openxmlformats.org/officeDocument/2006/relationships">
-  <c:date1904 val="0"/>
-  <c:roundedCorners val="1"/>
-  <c:chart>
-    <c:title>
-      <c:tx>
-        <c:rich>
-          <a:bodyPr/>
-          <a:lstStyle/>
-          <a:p>
-            <a:pPr>
-              <a:defRPr sz="1200" b="0" i="0" u="none" strike="noStrike">
-                <a:solidFill>
-                  <a:srgbClr val="0F4C5C"/>
-                </a:solidFill>
-                <a:latin typeface="+mn-lt"/>
-              </a:defRPr>
-            </a:pPr>
-            <a:r>
-              <a:rPr sz="1200" b="0" i="0" u="none" strike="noStrike">
-                <a:solidFill>
-                  <a:srgbClr val="0F4C5C"/>
-                </a:solidFill>
-                <a:latin typeface="+mn-lt"/>
-              </a:rPr>
-              <a:t>都市別フォロワー数（上位7）</a:t>
-            </a:r>
-          </a:p>
-        </c:rich>
-      </c:tx>
-      <c:layout/>
-      <c:overlay val="0"/>
-    </c:title>
-    <c:autoTitleDeleted val="0"/>
-    <c:plotArea>
-      <c:layout/>
-      <c:barChart>
-        <c:barDir val="bar"/>
-        <c:grouping val="clustered"/>
-        <c:varyColors val="0"/>
-        <c:ser>
-          <c:idx val="0"/>
-          <c:order val="0"/>
-          <c:tx>
-            <c:strRef>
-              <c:f>Sheet1!$B$1</c:f>
-              <c:strCache>
-                <c:ptCount val="1"/>
-                <c:pt idx="0">
-                  <c:v>フォロワー</c:v>
-                </c:pt>
-              </c:strCache>
-            </c:strRef>
-          </c:tx>
-          <c:spPr>
-            <a:solidFill>
-              <a:srgbClr val="2A9D8F"/>
-            </a:solidFill>
-            <a:effectLst/>
-          </c:spPr>
-          <c:invertIfNegative val="0"/>
-          <c:dLbls>
-            <c:numFmt formatCode="#,##0" sourceLinked="0"/>
-            <c:txPr>
-              <a:bodyPr/>
-              <a:lstStyle/>
-              <a:p>
-                <a:pPr>
-                  <a:defRPr b="0" i="0" strike="noStrike" sz="1000" u="none">
-                    <a:solidFill>
-                      <a:srgbClr val="1F2A30"/>
-                    </a:solidFill>
-                    <a:latin typeface="+mn-lt"/>
-                  </a:defRPr>
-                </a:pPr>
-              </a:p>
-            </c:txPr>
-            <c:showLegendKey val="0"/>
-            <c:showVal val="1"/>
-            <c:showCatName val="0"/>
-            <c:showSerName val="0"/>
-            <c:showPercent val="0"/>
-            <c:showBubbleSize val="0"/>
-            <c:showLeaderLines val="0"/>
-          </c:dLbls>
-          <c:cat>
-            <c:multiLvlStrRef>
-              <c:f>Sheet1!$A$2:$A$8</c:f>
-              <c:multiLvlStrCache>
-                <c:ptCount val="7"/>
-                <c:lvl>
-                  <c:pt idx="0">
-                    <c:v>札幌市</c:v>
-                  </c:pt>
-                  <c:pt idx="1">
-                    <c:v>大阪市</c:v>
-                  </c:pt>
-                  <c:pt idx="2">
-                    <c:v>横浜市</c:v>
-                  </c:pt>
-                  <c:pt idx="3">
-                    <c:v>名古屋市</c:v>
-                  </c:pt>
-                  <c:pt idx="4">
-                    <c:v>神戸市</c:v>
-                  </c:pt>
-                  <c:pt idx="5">
-                    <c:v>福岡市</c:v>
-                  </c:pt>
-                  <c:pt idx="6">
-                    <c:v>川崎市</c:v>
-                  </c:pt>
-                </c:lvl>
-              </c:multiLvlStrCache>
-            </c:multiLvlStrRef>
-          </c:cat>
-          <c:val>
-            <c:numRef>
-              <c:f>Sheet1!$B$2:$B$8</c:f>
-              <c:numCache>
-                <c:formatCode>General</c:formatCode>
-                <c:ptCount val="7"/>
-                <c:pt idx="0">
-                  <c:v>221</c:v>
-                </c:pt>
-                <c:pt idx="1">
-                  <c:v>197</c:v>
-                </c:pt>
-                <c:pt idx="2">
-                  <c:v>129</c:v>
-                </c:pt>
-                <c:pt idx="3">
-                  <c:v>117</c:v>
-                </c:pt>
-                <c:pt idx="4">
-                  <c:v>70</c:v>
-                </c:pt>
-                <c:pt idx="5">
-                  <c:v>67</c:v>
-                </c:pt>
-                <c:pt idx="6">
-                  <c:v>61</c:v>
-                </c:pt>
-              </c:numCache>
-            </c:numRef>
-          </c:val>
-        </c:ser>
-        <c:dLbls>
-          <c:numFmt formatCode="#,##0" sourceLinked="0"/>
-          <c:txPr>
-            <a:bodyPr/>
-            <a:lstStyle/>
-            <a:p>
-              <a:pPr>
-                <a:defRPr b="0" i="0" strike="noStrike" sz="1000" u="none">
-                  <a:solidFill>
-                    <a:srgbClr val="1F2A30"/>
-                  </a:solidFill>
-                  <a:latin typeface="+mn-lt"/>
-                </a:defRPr>
-              </a:pPr>
-            </a:p>
-          </c:txPr>
-          <c:showLegendKey val="0"/>
-          <c:showVal val="1"/>
-          <c:showCatName val="0"/>
-          <c:showSerName val="0"/>
-          <c:showPercent val="0"/>
-          <c:showBubbleSize val="0"/>
-          <c:showLeaderLines val="0"/>
-        </c:dLbls>
-        <c:gapWidth val="150"/>
-        <c:overlap val="0"/>
-        <c:axId val="2094734554"/>
-        <c:axId val="2094734552"/>
-        <c:axId val="2094734556"/>
-      </c:barChart>
-      <c:catAx>
-        <c:axId val="2094734554"/>
-        <c:scaling>
-          <c:orientation val="maxMin"/>
-        </c:scaling>
-        <c:delete val="0"/>
-        <c:axPos val="l"/>
-        <c:numFmt formatCode="General" sourceLinked="1"/>
-        <c:majorTickMark val="out"/>
-        <c:minorTickMark val="none"/>
-        <c:tickLblPos val="nextTo"/>
-        <c:spPr>
-          <a:ln w="12700" cap="flat">
-            <a:solidFill>
-              <a:srgbClr val="888888"/>
-            </a:solidFill>
-            <a:prstDash val="solid"/>
-            <a:round/>
-          </a:ln>
-        </c:spPr>
-        <c:txPr>
-          <a:bodyPr/>
-          <a:lstStyle/>
-          <a:p>
-            <a:pPr>
-              <a:defRPr sz="1000" b="0" i="0" u="none" strike="noStrike">
-                <a:solidFill>
-                  <a:srgbClr val="6B7A80"/>
-                </a:solidFill>
-                <a:latin typeface="+mn-lt"/>
-              </a:defRPr>
-            </a:pPr>
-            <a:endParaRPr lang="en-US"/>
-          </a:p>
-        </c:txPr>
-        <c:crossAx val="2094734552"/>
-        <c:crosses val="autoZero"/>
-        <c:auto val="1"/>
-        <c:lblAlgn val="ctr"/>
-        <c:noMultiLvlLbl val="1"/>
-      </c:catAx>
-      <c:valAx>
-        <c:axId val="2094734552"/>
-        <c:scaling>
-          <c:orientation val="minMax"/>
-        </c:scaling>
-        <c:delete val="0"/>
-        <c:axPos val="b"/>
-        <c:majorGridlines>
-          <c:spPr>
-            <a:ln w="6350" cap="flat">
-              <a:solidFill>
-                <a:srgbClr val="D7E3E1"/>
-              </a:solidFill>
-              <a:prstDash val="solid"/>
-              <a:round/>
-            </a:ln>
-          </c:spPr>
-        </c:majorGridlines>
-        <c:numFmt formatCode="General" sourceLinked="0"/>
-        <c:majorTickMark val="out"/>
-        <c:minorTickMark val="none"/>
-        <c:tickLblPos val="low"/>
-        <c:spPr>
-          <a:ln w="12700" cap="flat">
-            <a:solidFill>
-              <a:srgbClr val="888888"/>
-            </a:solidFill>
-            <a:prstDash val="solid"/>
-            <a:round/>
-          </a:ln>
-        </c:spPr>
-        <c:txPr>
-          <a:bodyPr/>
-          <a:lstStyle/>
-          <a:p>
-            <a:pPr>
-              <a:defRPr sz="1000" b="0" i="0" u="none" strike="noStrike">
-                <a:solidFill>
-                  <a:srgbClr val="6B7A80"/>
-                </a:solidFill>
-                <a:latin typeface="+mn-lt"/>
-              </a:defRPr>
-            </a:pPr>
-            <a:endParaRPr lang="en-US"/>
-          </a:p>
-        </c:txPr>
-        <c:crossAx val="2094734554"/>
-        <c:crosses val="autoZero"/>
-        <c:crossBetween val="between"/>
-      </c:valAx>
-      <c:spPr>
-        <a:noFill/>
-        <a:ln>
-          <a:noFill/>
-        </a:ln>
-        <a:effectLst/>
-      </c:spPr>
-    </c:plotArea>
-    <c:plotVisOnly val="1"/>
-    <c:dispBlanksAs val="span"/>
-  </c:chart>
-  <c:spPr>
-    <a:noFill/>
-    <a:ln>
-      <a:noFill/>
-    </a:ln>
-    <a:effectLst/>
-  </c:spPr>
-  <c:externalData r:id="rId1">
-    <c:autoUpdate val="0"/>
-  </c:externalData>
-</c:chartSpace>
-</file>
-
-<file path=ppt/charts/chart5.xml><?xml version="1.0" encoding="utf-8"?>
-<c:chartSpace xmlns:c="http://schemas.openxmlformats.org/drawingml/2006/chart" xmlns:a="http://schemas.openxmlformats.org/drawingml/2006/main" xmlns:r="http://schemas.openxmlformats.org/officeDocument/2006/relationships">
-  <c:date1904 val="0"/>
-  <c:roundedCorners val="1"/>
-  <c:chart>
-    <c:title>
-      <c:tx>
-        <c:rich>
-          <a:bodyPr/>
-          <a:lstStyle/>
-          <a:p>
-            <a:pPr>
-              <a:defRPr sz="1200" b="0" i="0" u="none" strike="noStrike">
-                <a:solidFill>
-                  <a:srgbClr val="0F4C5C"/>
-                </a:solidFill>
-                <a:latin typeface="+mn-lt"/>
-              </a:defRPr>
-            </a:pPr>
-            <a:r>
-              <a:rPr sz="1200" b="0" i="0" u="none" strike="noStrike">
-                <a:solidFill>
-                  <a:srgbClr val="0F4C5C"/>
-                </a:solidFill>
-                <a:latin typeface="+mn-lt"/>
-              </a:rPr>
-              <a:t>年齢別フォロワー数</a:t>
-            </a:r>
-          </a:p>
-        </c:rich>
-      </c:tx>
-      <c:layout/>
-      <c:overlay val="0"/>
-    </c:title>
-    <c:autoTitleDeleted val="0"/>
-    <c:plotArea>
-      <c:layout/>
-      <c:barChart>
-        <c:barDir val="col"/>
-        <c:grouping val="clustered"/>
-        <c:varyColors val="0"/>
-        <c:ser>
-          <c:idx val="0"/>
-          <c:order val="0"/>
-          <c:tx>
-            <c:strRef>
-              <c:f>Sheet1!$B$1</c:f>
-              <c:strCache>
-                <c:ptCount val="1"/>
-                <c:pt idx="0">
-                  <c:v>フォロワー</c:v>
-                </c:pt>
-              </c:strCache>
-            </c:strRef>
-          </c:tx>
-          <c:spPr>
-            <a:solidFill>
-              <a:srgbClr val="0F4C5C"/>
-            </a:solidFill>
-            <a:effectLst/>
-          </c:spPr>
-          <c:invertIfNegative val="0"/>
-          <c:dLbls>
-            <c:numFmt formatCode="#,##0" sourceLinked="0"/>
-            <c:txPr>
-              <a:bodyPr/>
-              <a:lstStyle/>
-              <a:p>
-                <a:pPr>
-                  <a:defRPr b="0" i="0" strike="noStrike" sz="1000" u="none">
-                    <a:solidFill>
-                      <a:srgbClr val="1F2A30"/>
-                    </a:solidFill>
-                    <a:latin typeface="+mn-lt"/>
-                  </a:defRPr>
-                </a:pPr>
-              </a:p>
-            </c:txPr>
-            <c:showLegendKey val="0"/>
-            <c:showVal val="1"/>
-            <c:showCatName val="0"/>
-            <c:showSerName val="0"/>
-            <c:showPercent val="0"/>
-            <c:showBubbleSize val="0"/>
-            <c:showLeaderLines val="0"/>
-          </c:dLbls>
-          <c:cat>
-            <c:multiLvlStrRef>
-              <c:f>Sheet1!$A$2:$A$7</c:f>
-              <c:multiLvlStrCache>
-                <c:ptCount val="6"/>
-                <c:lvl>
-                  <c:pt idx="0">
-                    <c:v>18-24</c:v>
-                  </c:pt>
-                  <c:pt idx="1">
-                    <c:v>25-34</c:v>
-                  </c:pt>
-                  <c:pt idx="2">
-                    <c:v>35-44</c:v>
-                  </c:pt>
-                  <c:pt idx="3">
-                    <c:v>45-54</c:v>
-                  </c:pt>
-                  <c:pt idx="4">
-                    <c:v>55-64</c:v>
-                  </c:pt>
-                  <c:pt idx="5">
-                    <c:v>65+</c:v>
-                  </c:pt>
-                </c:lvl>
-              </c:multiLvlStrCache>
-            </c:multiLvlStrRef>
-          </c:cat>
-          <c:val>
-            <c:numRef>
-              <c:f>Sheet1!$B$2:$B$7</c:f>
-              <c:numCache>
-                <c:formatCode>General</c:formatCode>
-                <c:ptCount val="6"/>
-                <c:pt idx="0">
-                  <c:v>245</c:v>
-                </c:pt>
-                <c:pt idx="1">
-                  <c:v>1118</c:v>
-                </c:pt>
-                <c:pt idx="2">
-                  <c:v>1527</c:v>
-                </c:pt>
-                <c:pt idx="3">
-                  <c:v>915</c:v>
-                </c:pt>
-                <c:pt idx="4">
-                  <c:v>374</c:v>
-                </c:pt>
-                <c:pt idx="5">
-                  <c:v>132</c:v>
-                </c:pt>
-              </c:numCache>
-            </c:numRef>
-          </c:val>
-        </c:ser>
-        <c:dLbls>
-          <c:numFmt formatCode="#,##0" sourceLinked="0"/>
-          <c:txPr>
-            <a:bodyPr/>
-            <a:lstStyle/>
-            <a:p>
-              <a:pPr>
-                <a:defRPr b="0" i="0" strike="noStrike" sz="1000" u="none">
-                  <a:solidFill>
-                    <a:srgbClr val="1F2A30"/>
-                  </a:solidFill>
-                  <a:latin typeface="+mn-lt"/>
-                </a:defRPr>
-              </a:pPr>
-            </a:p>
-          </c:txPr>
-          <c:showLegendKey val="0"/>
-          <c:showVal val="1"/>
-          <c:showCatName val="0"/>
-          <c:showSerName val="0"/>
-          <c:showPercent val="0"/>
-          <c:showBubbleSize val="0"/>
-          <c:showLeaderLines val="0"/>
-        </c:dLbls>
-        <c:gapWidth val="150"/>
-        <c:overlap val="0"/>
-        <c:axId val="2094734554"/>
-        <c:axId val="2094734552"/>
-        <c:axId val="2094734556"/>
-      </c:barChart>
-      <c:catAx>
-        <c:axId val="2094734554"/>
-        <c:scaling>
-          <c:orientation val="minMax"/>
-        </c:scaling>
-        <c:delete val="0"/>
-        <c:axPos val="b"/>
-        <c:numFmt formatCode="General" sourceLinked="1"/>
-        <c:majorTickMark val="out"/>
-        <c:minorTickMark val="none"/>
-        <c:tickLblPos val="low"/>
-        <c:spPr>
-          <a:ln w="12700" cap="flat">
-            <a:solidFill>
-              <a:srgbClr val="888888"/>
-            </a:solidFill>
-            <a:prstDash val="solid"/>
-            <a:round/>
-          </a:ln>
-        </c:spPr>
-        <c:txPr>
-          <a:bodyPr/>
-          <a:lstStyle/>
-          <a:p>
-            <a:pPr>
-              <a:defRPr sz="1000" b="0" i="0" u="none" strike="noStrike">
-                <a:solidFill>
-                  <a:srgbClr val="6B7A80"/>
-                </a:solidFill>
-                <a:latin typeface="+mn-lt"/>
-              </a:defRPr>
-            </a:pPr>
-            <a:endParaRPr lang="en-US"/>
-          </a:p>
-        </c:txPr>
-        <c:crossAx val="2094734552"/>
-        <c:crosses val="autoZero"/>
-        <c:auto val="1"/>
-        <c:lblAlgn val="ctr"/>
-        <c:noMultiLvlLbl val="1"/>
-      </c:catAx>
-      <c:valAx>
-        <c:axId val="2094734552"/>
-        <c:scaling>
-          <c:orientation val="minMax"/>
-        </c:scaling>
-        <c:delete val="0"/>
-        <c:axPos val="l"/>
-        <c:majorGridlines>
-          <c:spPr>
-            <a:ln w="6350" cap="flat">
-              <a:solidFill>
-                <a:srgbClr val="D7E3E1"/>
-              </a:solidFill>
-              <a:prstDash val="solid"/>
-              <a:round/>
-            </a:ln>
-          </c:spPr>
-        </c:majorGridlines>
-        <c:numFmt formatCode="#,##0" sourceLinked="0"/>
-        <c:majorTickMark val="out"/>
-        <c:minorTickMark val="none"/>
-        <c:tickLblPos val="nextTo"/>
-        <c:spPr>
-          <a:ln w="12700" cap="flat">
-            <a:solidFill>
-              <a:srgbClr val="888888"/>
-            </a:solidFill>
-            <a:prstDash val="solid"/>
-            <a:round/>
-          </a:ln>
-        </c:spPr>
-        <c:txPr>
-          <a:bodyPr/>
-          <a:lstStyle/>
-          <a:p>
-            <a:pPr>
-              <a:defRPr sz="1000" b="0" i="0" u="none" strike="noStrike">
-                <a:solidFill>
-                  <a:srgbClr val="6B7A80"/>
-                </a:solidFill>
-                <a:latin typeface="+mn-lt"/>
-              </a:defRPr>
-            </a:pPr>
-            <a:endParaRPr lang="en-US"/>
-          </a:p>
-        </c:txPr>
-        <c:crossAx val="2094734554"/>
-        <c:crosses val="autoZero"/>
-        <c:crossBetween val="between"/>
-      </c:valAx>
-      <c:spPr>
-        <a:noFill/>
-        <a:ln>
-          <a:noFill/>
-        </a:ln>
-        <a:effectLst/>
-      </c:spPr>
-    </c:plotArea>
-    <c:plotVisOnly val="1"/>
-    <c:dispBlanksAs val="span"/>
-  </c:chart>
-  <c:spPr>
-    <a:noFill/>
-    <a:ln>
-      <a:noFill/>
-    </a:ln>
-    <a:effectLst/>
-  </c:spPr>
-  <c:externalData r:id="rId1">
-    <c:autoUpdate val="0"/>
-  </c:externalData>
-</c:chartSpace>
 </file>
 
 <file path=ppt/notesMasters/notesMaster1.xml><?xml version="1.0" encoding="utf-8"?>
@@ -8581,22 +7110,30 @@
           </a:p>
         </p:txBody>
       </p:sp>
-      <p:graphicFrame>
-        <p:nvGraphicFramePr>
-          <p:cNvPr id="3" name="Chart 0" descr=""/>
-          <p:cNvGraphicFramePr/>
+      <p:pic>
+        <p:nvPicPr>
+          <p:cNvPr id="3" name="Image 0" descr="月別の平均表示回数">    </p:cNvPr>
+          <p:cNvPicPr>
+            <a:picLocks noChangeAspect="1"/>
+          </p:cNvPicPr>
           <p:nvPr/>
-        </p:nvGraphicFramePr>
-        <p:xfrm>
-          <a:off x="457200" y="1051560"/>
-          <a:ext cx="5486400" cy="3566160"/>
-        </p:xfrm>
-        <a:graphic xmlns:a="http://schemas.openxmlformats.org/drawingml/2006/main">
-          <a:graphicData uri="http://schemas.openxmlformats.org/drawingml/2006/chart">
-            <c:chart xmlns:c="http://schemas.openxmlformats.org/drawingml/2006/chart" r:id="rId1"/>
-          </a:graphicData>
-        </a:graphic>
-      </p:graphicFrame>
+        </p:nvPicPr>
+        <p:blipFill>
+          <a:blip r:embed="rId1"/>
+          <a:stretch>
+            <a:fillRect/>
+          </a:stretch>
+        </p:blipFill>
+        <p:spPr>
+          <a:xfrm>
+            <a:off x="457200" y="1051560"/>
+            <a:ext cx="5486400" cy="3566160"/>
+          </a:xfrm>
+          <a:prstGeom prst="rect">
+            <a:avLst/>
+          </a:prstGeom>
+        </p:spPr>
+      </p:pic>
       <p:sp>
         <p:nvSpPr>
           <p:cNvPr id="4" name="insight"/>
@@ -8839,38 +7376,54 @@
           </a:p>
         </p:txBody>
       </p:sp>
-      <p:graphicFrame>
-        <p:nvGraphicFramePr>
-          <p:cNvPr id="3" name="Chart 0" descr=""/>
-          <p:cNvGraphicFramePr/>
+      <p:pic>
+        <p:nvPicPr>
+          <p:cNvPr id="3" name="Image 0" descr="テーマ別の平均リーチ">    </p:cNvPr>
+          <p:cNvPicPr>
+            <a:picLocks noChangeAspect="1"/>
+          </p:cNvPicPr>
           <p:nvPr/>
-        </p:nvGraphicFramePr>
-        <p:xfrm>
-          <a:off x="457200" y="1051560"/>
-          <a:ext cx="4114800" cy="3566160"/>
-        </p:xfrm>
-        <a:graphic xmlns:a="http://schemas.openxmlformats.org/drawingml/2006/main">
-          <a:graphicData uri="http://schemas.openxmlformats.org/drawingml/2006/chart">
-            <c:chart xmlns:c="http://schemas.openxmlformats.org/drawingml/2006/chart" r:id="rId1"/>
-          </a:graphicData>
-        </a:graphic>
-      </p:graphicFrame>
-      <p:graphicFrame>
-        <p:nvGraphicFramePr>
-          <p:cNvPr id="4" name="Chart 1" descr=""/>
-          <p:cNvGraphicFramePr/>
+        </p:nvPicPr>
+        <p:blipFill>
+          <a:blip r:embed="rId1"/>
+          <a:stretch>
+            <a:fillRect/>
+          </a:stretch>
+        </p:blipFill>
+        <p:spPr>
+          <a:xfrm>
+            <a:off x="457200" y="1051560"/>
+            <a:ext cx="4114800" cy="3566160"/>
+          </a:xfrm>
+          <a:prstGeom prst="rect">
+            <a:avLst/>
+          </a:prstGeom>
+        </p:spPr>
+      </p:pic>
+      <p:pic>
+        <p:nvPicPr>
+          <p:cNvPr id="4" name="Image 1" descr="テーマ別のプロフィール訪問">    </p:cNvPr>
+          <p:cNvPicPr>
+            <a:picLocks noChangeAspect="1"/>
+          </p:cNvPicPr>
           <p:nvPr/>
-        </p:nvGraphicFramePr>
-        <p:xfrm>
-          <a:off x="4663440" y="1051560"/>
-          <a:ext cx="4023360" cy="3566160"/>
-        </p:xfrm>
-        <a:graphic xmlns:a="http://schemas.openxmlformats.org/drawingml/2006/main">
-          <a:graphicData uri="http://schemas.openxmlformats.org/drawingml/2006/chart">
-            <c:chart xmlns:c="http://schemas.openxmlformats.org/drawingml/2006/chart" r:id="rId2"/>
-          </a:graphicData>
-        </a:graphic>
-      </p:graphicFrame>
+        </p:nvPicPr>
+        <p:blipFill>
+          <a:blip r:embed="rId2"/>
+          <a:stretch>
+            <a:fillRect/>
+          </a:stretch>
+        </p:blipFill>
+        <p:spPr>
+          <a:xfrm>
+            <a:off x="4663440" y="1051560"/>
+            <a:ext cx="4023360" cy="3566160"/>
+          </a:xfrm>
+          <a:prstGeom prst="rect">
+            <a:avLst/>
+          </a:prstGeom>
+        </p:spPr>
+      </p:pic>
       <p:sp>
         <p:nvSpPr>
           <p:cNvPr id="5" name="Text 1"/>
@@ -10741,38 +9294,54 @@
           </a:p>
         </p:txBody>
       </p:sp>
-      <p:graphicFrame>
-        <p:nvGraphicFramePr>
-          <p:cNvPr id="3" name="Chart 0" descr=""/>
-          <p:cNvGraphicFramePr/>
+      <p:pic>
+        <p:nvPicPr>
+          <p:cNvPr id="3" name="Image 0" descr="都市別フォロワー数">    </p:cNvPr>
+          <p:cNvPicPr>
+            <a:picLocks noChangeAspect="1"/>
+          </p:cNvPicPr>
           <p:nvPr/>
-        </p:nvGraphicFramePr>
-        <p:xfrm>
-          <a:off x="457200" y="1051560"/>
-          <a:ext cx="4114800" cy="3566160"/>
-        </p:xfrm>
-        <a:graphic xmlns:a="http://schemas.openxmlformats.org/drawingml/2006/main">
-          <a:graphicData uri="http://schemas.openxmlformats.org/drawingml/2006/chart">
-            <c:chart xmlns:c="http://schemas.openxmlformats.org/drawingml/2006/chart" r:id="rId1"/>
-          </a:graphicData>
-        </a:graphic>
-      </p:graphicFrame>
-      <p:graphicFrame>
-        <p:nvGraphicFramePr>
-          <p:cNvPr id="4" name="Chart 1" descr=""/>
-          <p:cNvGraphicFramePr/>
+        </p:nvPicPr>
+        <p:blipFill>
+          <a:blip r:embed="rId1"/>
+          <a:stretch>
+            <a:fillRect/>
+          </a:stretch>
+        </p:blipFill>
+        <p:spPr>
+          <a:xfrm>
+            <a:off x="457200" y="1051560"/>
+            <a:ext cx="4114800" cy="3566160"/>
+          </a:xfrm>
+          <a:prstGeom prst="rect">
+            <a:avLst/>
+          </a:prstGeom>
+        </p:spPr>
+      </p:pic>
+      <p:pic>
+        <p:nvPicPr>
+          <p:cNvPr id="4" name="Image 1" descr="年齢別フォロワー数">    </p:cNvPr>
+          <p:cNvPicPr>
+            <a:picLocks noChangeAspect="1"/>
+          </p:cNvPicPr>
           <p:nvPr/>
-        </p:nvGraphicFramePr>
-        <p:xfrm>
-          <a:off x="4663440" y="1051560"/>
-          <a:ext cx="4023360" cy="3566160"/>
-        </p:xfrm>
-        <a:graphic xmlns:a="http://schemas.openxmlformats.org/drawingml/2006/main">
-          <a:graphicData uri="http://schemas.openxmlformats.org/drawingml/2006/chart">
-            <c:chart xmlns:c="http://schemas.openxmlformats.org/drawingml/2006/chart" r:id="rId2"/>
-          </a:graphicData>
-        </a:graphic>
-      </p:graphicFrame>
+        </p:nvPicPr>
+        <p:blipFill>
+          <a:blip r:embed="rId2"/>
+          <a:stretch>
+            <a:fillRect/>
+          </a:stretch>
+        </p:blipFill>
+        <p:spPr>
+          <a:xfrm>
+            <a:off x="4663440" y="1051560"/>
+            <a:ext cx="4023360" cy="3566160"/>
+          </a:xfrm>
+          <a:prstGeom prst="rect">
+            <a:avLst/>
+          </a:prstGeom>
+        </p:spPr>
+      </p:pic>
       <p:sp>
         <p:nvSpPr>
           <p:cNvPr id="5" name="Text 1"/>

</xml_diff>